<commit_message>
esilk compat: Cyrl supplemental font also for WordArt and script-only tags
Review follow-up: the WordArt shape-copy path (lcl_copyCharPropsToShape) resolved the latin font on its own and dropped the supplemental font; both paths now use TextCharacterProperties::getLatinFontData(). Script-only tags (sr-Cyrl, bs-Cyrl, kk-Cyrl, ...) map to LSO language IDs; check the explicit script and those IDs too. Test extended with an sr-Cyrl run.

Co-Authored-By: Claude Opus 5.5 (1M context) <noreply@anthropic.com>
Claude-Session: https://claude.ai/code/session_015fHjdkxQhAAB3juRZyobVX
Change-Id: I0813e0a57b25050b57f3e1c8d2b6f64f910e0a0d
</commit_message>
<xml_diff>
--- a/sd/qa/unit/data/pptx/esilk-theme-font-cyrl.pptx
+++ b/sd/qa/unit/data/pptx/esilk-theme-font-cyrl.pptx
@@ -149,6 +149,14 @@
                 <a:latin typeface="+mn-lt"/>
               </a:rPr>
               <a:t>Қазақ мәтіні</a:t>
+            </a:r>
+          </a:p>
+          <a:p>
+            <a:r>
+              <a:rPr lang="sr-Cyrl">
+                <a:latin typeface="+mn-lt"/>
+              </a:rPr>
+              <a:t>Ћирилица</a:t>
             </a:r>
           </a:p>
         </p:txBody>

</xml_diff>